<commit_message>
Updated prerequisites and Moran folder
</commit_message>
<xml_diff>
--- a/Sessions/Moran/Introduction_to_cheminformatics.pptx
+++ b/Sessions/Moran/Introduction_to_cheminformatics.pptx
@@ -5,7 +5,7 @@
     <p:sldMasterId id="2147483648" r:id="rId1"/>
   </p:sldMasterIdLst>
   <p:notesMasterIdLst>
-    <p:notesMasterId r:id="rId18"/>
+    <p:notesMasterId r:id="rId21"/>
   </p:notesMasterIdLst>
   <p:sldIdLst>
     <p:sldId id="256" r:id="rId2"/>
@@ -24,6 +24,9 @@
     <p:sldId id="1143" r:id="rId15"/>
     <p:sldId id="1142" r:id="rId16"/>
     <p:sldId id="1141" r:id="rId17"/>
+    <p:sldId id="1149" r:id="rId18"/>
+    <p:sldId id="1148" r:id="rId19"/>
+    <p:sldId id="1150" r:id="rId20"/>
   </p:sldIdLst>
   <p:sldSz cx="12192000" cy="6858000"/>
   <p:notesSz cx="6858000" cy="9144000"/>
@@ -212,7 +215,7 @@
           <a:p>
             <a:fld id="{DD491AF5-2077-4BA1-B113-2310F8AFC2A1}" type="datetimeFigureOut">
               <a:rPr lang="en-US" smtClean="0"/>
-              <a:t>5/11/2026</a:t>
+              <a:t>5/20/2026</a:t>
             </a:fld>
             <a:endParaRPr lang="en-US"/>
           </a:p>
@@ -911,6 +914,330 @@
 </p:notes>
 </file>
 
+<file path=ppt/notesSlides/notesSlide5.xml><?xml version="1.0" encoding="utf-8"?>
+<p:notes xmlns:a="http://schemas.openxmlformats.org/drawingml/2006/main" xmlns:r="http://schemas.openxmlformats.org/officeDocument/2006/relationships" xmlns:p="http://schemas.openxmlformats.org/presentationml/2006/main">
+  <p:cSld>
+    <p:spTree>
+      <p:nvGrpSpPr>
+        <p:cNvPr id="1" name="">
+          <a:extLst>
+            <a:ext uri="{FF2B5EF4-FFF2-40B4-BE49-F238E27FC236}">
+              <a16:creationId xmlns:a16="http://schemas.microsoft.com/office/drawing/2014/main" id="{010D4CF8-0178-0D90-E0E3-186DF43D6991}"/>
+            </a:ext>
+          </a:extLst>
+        </p:cNvPr>
+        <p:cNvGrpSpPr/>
+        <p:nvPr/>
+      </p:nvGrpSpPr>
+      <p:grpSpPr>
+        <a:xfrm>
+          <a:off x="0" y="0"/>
+          <a:ext cx="0" cy="0"/>
+          <a:chOff x="0" y="0"/>
+          <a:chExt cx="0" cy="0"/>
+        </a:xfrm>
+      </p:grpSpPr>
+      <p:sp>
+        <p:nvSpPr>
+          <p:cNvPr id="2" name="Slide Image Placeholder 1">
+            <a:extLst>
+              <a:ext uri="{FF2B5EF4-FFF2-40B4-BE49-F238E27FC236}">
+                <a16:creationId xmlns:a16="http://schemas.microsoft.com/office/drawing/2014/main" id="{45CA97EA-0803-7F7B-B648-04A0FCA7C265}"/>
+              </a:ext>
+            </a:extLst>
+          </p:cNvPr>
+          <p:cNvSpPr>
+            <a:spLocks noGrp="1" noRot="1" noChangeAspect="1"/>
+          </p:cNvSpPr>
+          <p:nvPr>
+            <p:ph type="sldImg"/>
+          </p:nvPr>
+        </p:nvSpPr>
+        <p:spPr/>
+      </p:sp>
+      <p:sp>
+        <p:nvSpPr>
+          <p:cNvPr id="3" name="Notes Placeholder 2">
+            <a:extLst>
+              <a:ext uri="{FF2B5EF4-FFF2-40B4-BE49-F238E27FC236}">
+                <a16:creationId xmlns:a16="http://schemas.microsoft.com/office/drawing/2014/main" id="{85B51E72-4C67-638A-01AC-EFC92C1AA4DF}"/>
+              </a:ext>
+            </a:extLst>
+          </p:cNvPr>
+          <p:cNvSpPr>
+            <a:spLocks noGrp="1"/>
+          </p:cNvSpPr>
+          <p:nvPr>
+            <p:ph type="body" idx="1"/>
+          </p:nvPr>
+        </p:nvSpPr>
+        <p:spPr/>
+        <p:txBody>
+          <a:bodyPr/>
+          <a:lstStyle/>
+          <a:p>
+            <a:endParaRPr lang="en-US" dirty="0"/>
+          </a:p>
+        </p:txBody>
+      </p:sp>
+      <p:sp>
+        <p:nvSpPr>
+          <p:cNvPr id="4" name="Slide Number Placeholder 3">
+            <a:extLst>
+              <a:ext uri="{FF2B5EF4-FFF2-40B4-BE49-F238E27FC236}">
+                <a16:creationId xmlns:a16="http://schemas.microsoft.com/office/drawing/2014/main" id="{F92104A0-4200-2EAB-B264-48CCC301565A}"/>
+              </a:ext>
+            </a:extLst>
+          </p:cNvPr>
+          <p:cNvSpPr>
+            <a:spLocks noGrp="1"/>
+          </p:cNvSpPr>
+          <p:nvPr>
+            <p:ph type="sldNum" sz="quarter" idx="5"/>
+          </p:nvPr>
+        </p:nvSpPr>
+        <p:spPr/>
+        <p:txBody>
+          <a:bodyPr/>
+          <a:lstStyle/>
+          <a:p>
+            <a:fld id="{84682E02-BE67-4161-A544-735639CA5DF4}" type="slidenum">
+              <a:rPr lang="en-US" smtClean="0"/>
+              <a:t>17</a:t>
+            </a:fld>
+            <a:endParaRPr lang="en-US"/>
+          </a:p>
+        </p:txBody>
+      </p:sp>
+    </p:spTree>
+    <p:extLst>
+      <p:ext uri="{BB962C8B-B14F-4D97-AF65-F5344CB8AC3E}">
+        <p14:creationId xmlns:p14="http://schemas.microsoft.com/office/powerpoint/2010/main" val="3670737574"/>
+      </p:ext>
+    </p:extLst>
+  </p:cSld>
+  <p:clrMapOvr>
+    <a:masterClrMapping/>
+  </p:clrMapOvr>
+</p:notes>
+</file>
+
+<file path=ppt/notesSlides/notesSlide6.xml><?xml version="1.0" encoding="utf-8"?>
+<p:notes xmlns:a="http://schemas.openxmlformats.org/drawingml/2006/main" xmlns:r="http://schemas.openxmlformats.org/officeDocument/2006/relationships" xmlns:p="http://schemas.openxmlformats.org/presentationml/2006/main">
+  <p:cSld>
+    <p:spTree>
+      <p:nvGrpSpPr>
+        <p:cNvPr id="1" name="">
+          <a:extLst>
+            <a:ext uri="{FF2B5EF4-FFF2-40B4-BE49-F238E27FC236}">
+              <a16:creationId xmlns:a16="http://schemas.microsoft.com/office/drawing/2014/main" id="{99F79410-F8FF-6B4E-52FF-39FAB23C8087}"/>
+            </a:ext>
+          </a:extLst>
+        </p:cNvPr>
+        <p:cNvGrpSpPr/>
+        <p:nvPr/>
+      </p:nvGrpSpPr>
+      <p:grpSpPr>
+        <a:xfrm>
+          <a:off x="0" y="0"/>
+          <a:ext cx="0" cy="0"/>
+          <a:chOff x="0" y="0"/>
+          <a:chExt cx="0" cy="0"/>
+        </a:xfrm>
+      </p:grpSpPr>
+      <p:sp>
+        <p:nvSpPr>
+          <p:cNvPr id="2" name="Slide Image Placeholder 1">
+            <a:extLst>
+              <a:ext uri="{FF2B5EF4-FFF2-40B4-BE49-F238E27FC236}">
+                <a16:creationId xmlns:a16="http://schemas.microsoft.com/office/drawing/2014/main" id="{61B6028A-ADE2-2F1B-FBBA-5008263DD9FF}"/>
+              </a:ext>
+            </a:extLst>
+          </p:cNvPr>
+          <p:cNvSpPr>
+            <a:spLocks noGrp="1" noRot="1" noChangeAspect="1"/>
+          </p:cNvSpPr>
+          <p:nvPr>
+            <p:ph type="sldImg"/>
+          </p:nvPr>
+        </p:nvSpPr>
+        <p:spPr/>
+      </p:sp>
+      <p:sp>
+        <p:nvSpPr>
+          <p:cNvPr id="3" name="Notes Placeholder 2">
+            <a:extLst>
+              <a:ext uri="{FF2B5EF4-FFF2-40B4-BE49-F238E27FC236}">
+                <a16:creationId xmlns:a16="http://schemas.microsoft.com/office/drawing/2014/main" id="{37A02223-1DEA-63AE-E8F9-706CBF2336E7}"/>
+              </a:ext>
+            </a:extLst>
+          </p:cNvPr>
+          <p:cNvSpPr>
+            <a:spLocks noGrp="1"/>
+          </p:cNvSpPr>
+          <p:nvPr>
+            <p:ph type="body" idx="1"/>
+          </p:nvPr>
+        </p:nvSpPr>
+        <p:spPr/>
+        <p:txBody>
+          <a:bodyPr/>
+          <a:lstStyle/>
+          <a:p>
+            <a:endParaRPr lang="en-US" dirty="0"/>
+          </a:p>
+        </p:txBody>
+      </p:sp>
+      <p:sp>
+        <p:nvSpPr>
+          <p:cNvPr id="4" name="Slide Number Placeholder 3">
+            <a:extLst>
+              <a:ext uri="{FF2B5EF4-FFF2-40B4-BE49-F238E27FC236}">
+                <a16:creationId xmlns:a16="http://schemas.microsoft.com/office/drawing/2014/main" id="{68CF3343-4AB1-A6A9-EDBD-F0FEFA28F431}"/>
+              </a:ext>
+            </a:extLst>
+          </p:cNvPr>
+          <p:cNvSpPr>
+            <a:spLocks noGrp="1"/>
+          </p:cNvSpPr>
+          <p:nvPr>
+            <p:ph type="sldNum" sz="quarter" idx="5"/>
+          </p:nvPr>
+        </p:nvSpPr>
+        <p:spPr/>
+        <p:txBody>
+          <a:bodyPr/>
+          <a:lstStyle/>
+          <a:p>
+            <a:fld id="{84682E02-BE67-4161-A544-735639CA5DF4}" type="slidenum">
+              <a:rPr lang="en-US" smtClean="0"/>
+              <a:t>18</a:t>
+            </a:fld>
+            <a:endParaRPr lang="en-US"/>
+          </a:p>
+        </p:txBody>
+      </p:sp>
+    </p:spTree>
+    <p:extLst>
+      <p:ext uri="{BB962C8B-B14F-4D97-AF65-F5344CB8AC3E}">
+        <p14:creationId xmlns:p14="http://schemas.microsoft.com/office/powerpoint/2010/main" val="1833937160"/>
+      </p:ext>
+    </p:extLst>
+  </p:cSld>
+  <p:clrMapOvr>
+    <a:masterClrMapping/>
+  </p:clrMapOvr>
+</p:notes>
+</file>
+
+<file path=ppt/notesSlides/notesSlide7.xml><?xml version="1.0" encoding="utf-8"?>
+<p:notes xmlns:a="http://schemas.openxmlformats.org/drawingml/2006/main" xmlns:r="http://schemas.openxmlformats.org/officeDocument/2006/relationships" xmlns:p="http://schemas.openxmlformats.org/presentationml/2006/main">
+  <p:cSld>
+    <p:spTree>
+      <p:nvGrpSpPr>
+        <p:cNvPr id="1" name="">
+          <a:extLst>
+            <a:ext uri="{FF2B5EF4-FFF2-40B4-BE49-F238E27FC236}">
+              <a16:creationId xmlns:a16="http://schemas.microsoft.com/office/drawing/2014/main" id="{406E8A42-A95D-C37F-6FBD-1922FFF2CCAA}"/>
+            </a:ext>
+          </a:extLst>
+        </p:cNvPr>
+        <p:cNvGrpSpPr/>
+        <p:nvPr/>
+      </p:nvGrpSpPr>
+      <p:grpSpPr>
+        <a:xfrm>
+          <a:off x="0" y="0"/>
+          <a:ext cx="0" cy="0"/>
+          <a:chOff x="0" y="0"/>
+          <a:chExt cx="0" cy="0"/>
+        </a:xfrm>
+      </p:grpSpPr>
+      <p:sp>
+        <p:nvSpPr>
+          <p:cNvPr id="2" name="Slide Image Placeholder 1">
+            <a:extLst>
+              <a:ext uri="{FF2B5EF4-FFF2-40B4-BE49-F238E27FC236}">
+                <a16:creationId xmlns:a16="http://schemas.microsoft.com/office/drawing/2014/main" id="{7B535E88-6A3C-9CD7-DE73-4D4DD14500DE}"/>
+              </a:ext>
+            </a:extLst>
+          </p:cNvPr>
+          <p:cNvSpPr>
+            <a:spLocks noGrp="1" noRot="1" noChangeAspect="1"/>
+          </p:cNvSpPr>
+          <p:nvPr>
+            <p:ph type="sldImg"/>
+          </p:nvPr>
+        </p:nvSpPr>
+        <p:spPr/>
+      </p:sp>
+      <p:sp>
+        <p:nvSpPr>
+          <p:cNvPr id="3" name="Notes Placeholder 2">
+            <a:extLst>
+              <a:ext uri="{FF2B5EF4-FFF2-40B4-BE49-F238E27FC236}">
+                <a16:creationId xmlns:a16="http://schemas.microsoft.com/office/drawing/2014/main" id="{A451BD90-4ED8-2C82-EF3D-1DEDB2AE8537}"/>
+              </a:ext>
+            </a:extLst>
+          </p:cNvPr>
+          <p:cNvSpPr>
+            <a:spLocks noGrp="1"/>
+          </p:cNvSpPr>
+          <p:nvPr>
+            <p:ph type="body" idx="1"/>
+          </p:nvPr>
+        </p:nvSpPr>
+        <p:spPr/>
+        <p:txBody>
+          <a:bodyPr/>
+          <a:lstStyle/>
+          <a:p>
+            <a:endParaRPr lang="en-US" dirty="0"/>
+          </a:p>
+        </p:txBody>
+      </p:sp>
+      <p:sp>
+        <p:nvSpPr>
+          <p:cNvPr id="4" name="Slide Number Placeholder 3">
+            <a:extLst>
+              <a:ext uri="{FF2B5EF4-FFF2-40B4-BE49-F238E27FC236}">
+                <a16:creationId xmlns:a16="http://schemas.microsoft.com/office/drawing/2014/main" id="{CBF44FC5-B881-54F5-15BD-99B91DDA75D8}"/>
+              </a:ext>
+            </a:extLst>
+          </p:cNvPr>
+          <p:cNvSpPr>
+            <a:spLocks noGrp="1"/>
+          </p:cNvSpPr>
+          <p:nvPr>
+            <p:ph type="sldNum" sz="quarter" idx="5"/>
+          </p:nvPr>
+        </p:nvSpPr>
+        <p:spPr/>
+        <p:txBody>
+          <a:bodyPr/>
+          <a:lstStyle/>
+          <a:p>
+            <a:fld id="{84682E02-BE67-4161-A544-735639CA5DF4}" type="slidenum">
+              <a:rPr lang="en-US" smtClean="0"/>
+              <a:t>19</a:t>
+            </a:fld>
+            <a:endParaRPr lang="en-US"/>
+          </a:p>
+        </p:txBody>
+      </p:sp>
+    </p:spTree>
+    <p:extLst>
+      <p:ext uri="{BB962C8B-B14F-4D97-AF65-F5344CB8AC3E}">
+        <p14:creationId xmlns:p14="http://schemas.microsoft.com/office/powerpoint/2010/main" val="3025763471"/>
+      </p:ext>
+    </p:extLst>
+  </p:cSld>
+  <p:clrMapOvr>
+    <a:masterClrMapping/>
+  </p:clrMapOvr>
+</p:notes>
+</file>
+
 <file path=ppt/slideLayouts/slideLayout1.xml><?xml version="1.0" encoding="utf-8"?>
 <p:sldLayout xmlns:a="http://schemas.openxmlformats.org/drawingml/2006/main" xmlns:r="http://schemas.openxmlformats.org/officeDocument/2006/relationships" xmlns:p="http://schemas.openxmlformats.org/presentationml/2006/main" type="title" preserve="1">
   <p:cSld name="Title Slide">
@@ -1058,7 +1385,7 @@
           <a:p>
             <a:fld id="{BCC9E1F9-83F8-4EE8-BA17-07AD29752570}" type="datetimeFigureOut">
               <a:rPr lang="en-US" smtClean="0"/>
-              <a:t>5/11/2026</a:t>
+              <a:t>5/20/2026</a:t>
             </a:fld>
             <a:endParaRPr lang="en-US"/>
           </a:p>
@@ -1256,7 +1583,7 @@
           <a:p>
             <a:fld id="{BCC9E1F9-83F8-4EE8-BA17-07AD29752570}" type="datetimeFigureOut">
               <a:rPr lang="en-US" smtClean="0"/>
-              <a:t>5/11/2026</a:t>
+              <a:t>5/20/2026</a:t>
             </a:fld>
             <a:endParaRPr lang="en-US"/>
           </a:p>
@@ -1464,7 +1791,7 @@
           <a:p>
             <a:fld id="{BCC9E1F9-83F8-4EE8-BA17-07AD29752570}" type="datetimeFigureOut">
               <a:rPr lang="en-US" smtClean="0"/>
-              <a:t>5/11/2026</a:t>
+              <a:t>5/20/2026</a:t>
             </a:fld>
             <a:endParaRPr lang="en-US"/>
           </a:p>
@@ -1662,7 +1989,7 @@
           <a:p>
             <a:fld id="{BCC9E1F9-83F8-4EE8-BA17-07AD29752570}" type="datetimeFigureOut">
               <a:rPr lang="en-US" smtClean="0"/>
-              <a:t>5/11/2026</a:t>
+              <a:t>5/20/2026</a:t>
             </a:fld>
             <a:endParaRPr lang="en-US"/>
           </a:p>
@@ -1937,7 +2264,7 @@
           <a:p>
             <a:fld id="{BCC9E1F9-83F8-4EE8-BA17-07AD29752570}" type="datetimeFigureOut">
               <a:rPr lang="en-US" smtClean="0"/>
-              <a:t>5/11/2026</a:t>
+              <a:t>5/20/2026</a:t>
             </a:fld>
             <a:endParaRPr lang="en-US"/>
           </a:p>
@@ -2202,7 +2529,7 @@
           <a:p>
             <a:fld id="{BCC9E1F9-83F8-4EE8-BA17-07AD29752570}" type="datetimeFigureOut">
               <a:rPr lang="en-US" smtClean="0"/>
-              <a:t>5/11/2026</a:t>
+              <a:t>5/20/2026</a:t>
             </a:fld>
             <a:endParaRPr lang="en-US"/>
           </a:p>
@@ -2614,7 +2941,7 @@
           <a:p>
             <a:fld id="{BCC9E1F9-83F8-4EE8-BA17-07AD29752570}" type="datetimeFigureOut">
               <a:rPr lang="en-US" smtClean="0"/>
-              <a:t>5/11/2026</a:t>
+              <a:t>5/20/2026</a:t>
             </a:fld>
             <a:endParaRPr lang="en-US"/>
           </a:p>
@@ -2755,7 +3082,7 @@
           <a:p>
             <a:fld id="{BCC9E1F9-83F8-4EE8-BA17-07AD29752570}" type="datetimeFigureOut">
               <a:rPr lang="en-US" smtClean="0"/>
-              <a:t>5/11/2026</a:t>
+              <a:t>5/20/2026</a:t>
             </a:fld>
             <a:endParaRPr lang="en-US"/>
           </a:p>
@@ -2868,7 +3195,7 @@
           <a:p>
             <a:fld id="{BCC9E1F9-83F8-4EE8-BA17-07AD29752570}" type="datetimeFigureOut">
               <a:rPr lang="en-US" smtClean="0"/>
-              <a:t>5/11/2026</a:t>
+              <a:t>5/20/2026</a:t>
             </a:fld>
             <a:endParaRPr lang="en-US"/>
           </a:p>
@@ -3179,7 +3506,7 @@
           <a:p>
             <a:fld id="{BCC9E1F9-83F8-4EE8-BA17-07AD29752570}" type="datetimeFigureOut">
               <a:rPr lang="en-US" smtClean="0"/>
-              <a:t>5/11/2026</a:t>
+              <a:t>5/20/2026</a:t>
             </a:fld>
             <a:endParaRPr lang="en-US"/>
           </a:p>
@@ -3467,7 +3794,7 @@
           <a:p>
             <a:fld id="{BCC9E1F9-83F8-4EE8-BA17-07AD29752570}" type="datetimeFigureOut">
               <a:rPr lang="en-US" smtClean="0"/>
-              <a:t>5/11/2026</a:t>
+              <a:t>5/20/2026</a:t>
             </a:fld>
             <a:endParaRPr lang="en-US"/>
           </a:p>
@@ -3708,7 +4035,7 @@
           <a:p>
             <a:fld id="{BCC9E1F9-83F8-4EE8-BA17-07AD29752570}" type="datetimeFigureOut">
               <a:rPr lang="en-US" smtClean="0"/>
-              <a:t>5/11/2026</a:t>
+              <a:t>5/20/2026</a:t>
             </a:fld>
             <a:endParaRPr lang="en-US"/>
           </a:p>
@@ -4274,8 +4601,8 @@
         </p:nvSpPr>
         <p:spPr>
           <a:xfrm>
-            <a:off x="280626" y="2228671"/>
-            <a:ext cx="11100819" cy="2400657"/>
+            <a:off x="284498" y="1951672"/>
+            <a:ext cx="11100819" cy="2954655"/>
           </a:xfrm>
           <a:prstGeom prst="rect">
             <a:avLst/>
@@ -4322,13 +4649,21 @@
           </a:p>
           <a:p>
             <a:pPr algn="ctr"/>
+            <a:endParaRPr lang="en-US" sz="4000" dirty="0">
+              <a:solidFill>
+                <a:schemeClr val="tx1"/>
+              </a:solidFill>
+            </a:endParaRPr>
+          </a:p>
+          <a:p>
+            <a:pPr algn="ctr"/>
             <a:r>
               <a:rPr lang="en-US" sz="3200" dirty="0">
                 <a:solidFill>
                   <a:schemeClr val="tx1"/>
                 </a:solidFill>
               </a:rPr>
-              <a:t>Itzel Muro Puente</a:t>
+              <a:t>Author: Itzel Muro Puente</a:t>
             </a:r>
           </a:p>
           <a:p>
@@ -4339,7 +4674,7 @@
                   <a:schemeClr val="tx1"/>
                 </a:solidFill>
               </a:rPr>
-              <a:t>May 13</a:t>
+              <a:t>May 20</a:t>
             </a:r>
             <a:r>
               <a:rPr lang="en-US" sz="2800" baseline="30000" dirty="0">
@@ -4421,7 +4756,7 @@
         </p:nvSpPr>
         <p:spPr>
           <a:xfrm>
-            <a:off x="0" y="5741171"/>
+            <a:off x="0" y="5690883"/>
             <a:ext cx="12192000" cy="1168979"/>
           </a:xfrm>
           <a:prstGeom prst="rect">
@@ -9839,6 +10174,1765 @@
     <p:extLst>
       <p:ext uri="{BB962C8B-B14F-4D97-AF65-F5344CB8AC3E}">
         <p14:creationId xmlns:p14="http://schemas.microsoft.com/office/powerpoint/2010/main" val="1246581216"/>
+      </p:ext>
+    </p:extLst>
+  </p:cSld>
+  <p:clrMapOvr>
+    <a:masterClrMapping/>
+  </p:clrMapOvr>
+</p:sld>
+</file>
+
+<file path=ppt/slides/slide17.xml><?xml version="1.0" encoding="utf-8"?>
+<p:sld xmlns:a="http://schemas.openxmlformats.org/drawingml/2006/main" xmlns:r="http://schemas.openxmlformats.org/officeDocument/2006/relationships" xmlns:p="http://schemas.openxmlformats.org/presentationml/2006/main">
+  <p:cSld>
+    <p:spTree>
+      <p:nvGrpSpPr>
+        <p:cNvPr id="1" name="">
+          <a:extLst>
+            <a:ext uri="{FF2B5EF4-FFF2-40B4-BE49-F238E27FC236}">
+              <a16:creationId xmlns:a16="http://schemas.microsoft.com/office/drawing/2014/main" id="{692C6D3B-D870-6FAF-56F8-201AF7F36636}"/>
+            </a:ext>
+          </a:extLst>
+        </p:cNvPr>
+        <p:cNvGrpSpPr/>
+        <p:nvPr/>
+      </p:nvGrpSpPr>
+      <p:grpSpPr>
+        <a:xfrm>
+          <a:off x="0" y="0"/>
+          <a:ext cx="0" cy="0"/>
+          <a:chOff x="0" y="0"/>
+          <a:chExt cx="0" cy="0"/>
+        </a:xfrm>
+      </p:grpSpPr>
+      <p:cxnSp>
+        <p:nvCxnSpPr>
+          <p:cNvPr id="4" name="Straight Connector 3">
+            <a:extLst>
+              <a:ext uri="{FF2B5EF4-FFF2-40B4-BE49-F238E27FC236}">
+                <a16:creationId xmlns:a16="http://schemas.microsoft.com/office/drawing/2014/main" id="{8F1F43B2-C560-8219-0B9D-44BA3ACA4D81}"/>
+              </a:ext>
+            </a:extLst>
+          </p:cNvPr>
+          <p:cNvCxnSpPr>
+            <a:cxnSpLocks/>
+          </p:cNvCxnSpPr>
+          <p:nvPr/>
+        </p:nvCxnSpPr>
+        <p:spPr>
+          <a:xfrm>
+            <a:off x="399700" y="894492"/>
+            <a:ext cx="11361770" cy="0"/>
+          </a:xfrm>
+          <a:prstGeom prst="line">
+            <a:avLst/>
+          </a:prstGeom>
+          <a:ln w="38100">
+            <a:solidFill>
+              <a:srgbClr val="237194"/>
+            </a:solidFill>
+          </a:ln>
+        </p:spPr>
+        <p:style>
+          <a:lnRef idx="2">
+            <a:schemeClr val="accent6"/>
+          </a:lnRef>
+          <a:fillRef idx="0">
+            <a:schemeClr val="accent6"/>
+          </a:fillRef>
+          <a:effectRef idx="1">
+            <a:schemeClr val="accent6"/>
+          </a:effectRef>
+          <a:fontRef idx="minor">
+            <a:schemeClr val="tx1"/>
+          </a:fontRef>
+        </p:style>
+      </p:cxnSp>
+      <p:sp>
+        <p:nvSpPr>
+          <p:cNvPr id="5" name="Title 1">
+            <a:extLst>
+              <a:ext uri="{FF2B5EF4-FFF2-40B4-BE49-F238E27FC236}">
+                <a16:creationId xmlns:a16="http://schemas.microsoft.com/office/drawing/2014/main" id="{783AD0EC-205A-FA2F-F852-00165B4597BB}"/>
+              </a:ext>
+            </a:extLst>
+          </p:cNvPr>
+          <p:cNvSpPr txBox="1">
+            <a:spLocks/>
+          </p:cNvSpPr>
+          <p:nvPr/>
+        </p:nvSpPr>
+        <p:spPr>
+          <a:xfrm>
+            <a:off x="284498" y="83955"/>
+            <a:ext cx="11616350" cy="738664"/>
+          </a:xfrm>
+          <a:prstGeom prst="rect">
+            <a:avLst/>
+          </a:prstGeom>
+        </p:spPr>
+        <p:txBody>
+          <a:bodyPr vert="horz" wrap="square" lIns="91440" tIns="91440" rIns="91440" bIns="91440" rtlCol="0" anchor="b" anchorCtr="0">
+            <a:spAutoFit/>
+          </a:bodyPr>
+          <a:lstStyle>
+            <a:lvl1pPr algn="l" defTabSz="699614" rtl="0" eaLnBrk="1" latinLnBrk="0" hangingPunct="1">
+              <a:spcBef>
+                <a:spcPct val="0"/>
+              </a:spcBef>
+              <a:buNone/>
+              <a:defRPr sz="5400" b="0" i="0" kern="1200">
+                <a:solidFill>
+                  <a:schemeClr val="tx2"/>
+                </a:solidFill>
+                <a:latin typeface="Vitesse Light" charset="0"/>
+                <a:ea typeface="Vitesse Light" charset="0"/>
+                <a:cs typeface="Vitesse Light" charset="0"/>
+              </a:defRPr>
+            </a:lvl1pPr>
+          </a:lstStyle>
+          <a:p>
+            <a:r>
+              <a:rPr lang="es-ES" sz="3600" dirty="0" err="1">
+                <a:solidFill>
+                  <a:schemeClr val="tx1"/>
+                </a:solidFill>
+              </a:rPr>
+              <a:t>Transition</a:t>
+            </a:r>
+            <a:r>
+              <a:rPr lang="es-ES" sz="3600" dirty="0">
+                <a:solidFill>
+                  <a:schemeClr val="tx1"/>
+                </a:solidFill>
+              </a:rPr>
+              <a:t> metal complexes </a:t>
+            </a:r>
+            <a:r>
+              <a:rPr lang="en-US" sz="3600" dirty="0">
+                <a:solidFill>
+                  <a:schemeClr val="tx1"/>
+                </a:solidFill>
+              </a:rPr>
+              <a:t>SMILES</a:t>
+            </a:r>
+            <a:endParaRPr lang="es-ES" sz="3600" dirty="0">
+              <a:solidFill>
+                <a:schemeClr val="tx1"/>
+              </a:solidFill>
+            </a:endParaRPr>
+          </a:p>
+        </p:txBody>
+      </p:sp>
+      <p:pic>
+        <p:nvPicPr>
+          <p:cNvPr id="6" name="Picture 5" descr="A picture containing arrow&#10;&#10;Description automatically generated">
+            <a:extLst>
+              <a:ext uri="{FF2B5EF4-FFF2-40B4-BE49-F238E27FC236}">
+                <a16:creationId xmlns:a16="http://schemas.microsoft.com/office/drawing/2014/main" id="{C9EFC76F-E4DF-1258-EF92-0D2429F1F24E}"/>
+              </a:ext>
+            </a:extLst>
+          </p:cNvPr>
+          <p:cNvPicPr>
+            <a:picLocks noChangeAspect="1"/>
+          </p:cNvPicPr>
+          <p:nvPr/>
+        </p:nvPicPr>
+        <p:blipFill>
+          <a:blip r:embed="rId3"/>
+          <a:stretch>
+            <a:fillRect/>
+          </a:stretch>
+        </p:blipFill>
+        <p:spPr>
+          <a:xfrm>
+            <a:off x="10787654" y="13477"/>
+            <a:ext cx="1244134" cy="830042"/>
+          </a:xfrm>
+          <a:prstGeom prst="rect">
+            <a:avLst/>
+          </a:prstGeom>
+        </p:spPr>
+      </p:pic>
+      <p:pic>
+        <p:nvPicPr>
+          <p:cNvPr id="9" name="Picture 8" descr="IUI Mixto de Síntesis Química y Catálisis Homogenea (ISQCH) | Universidad  de Zaragoza">
+            <a:extLst>
+              <a:ext uri="{FF2B5EF4-FFF2-40B4-BE49-F238E27FC236}">
+                <a16:creationId xmlns:a16="http://schemas.microsoft.com/office/drawing/2014/main" id="{41AA3945-8CB6-111C-A6CF-271CC1941AED}"/>
+              </a:ext>
+            </a:extLst>
+          </p:cNvPr>
+          <p:cNvPicPr>
+            <a:picLocks noChangeAspect="1" noChangeArrowheads="1"/>
+          </p:cNvPicPr>
+          <p:nvPr/>
+        </p:nvPicPr>
+        <p:blipFill>
+          <a:blip r:embed="rId4">
+            <a:extLst>
+              <a:ext uri="{28A0092B-C50C-407E-A947-70E740481C1C}">
+                <a14:useLocalDpi xmlns:a14="http://schemas.microsoft.com/office/drawing/2010/main" val="0"/>
+              </a:ext>
+            </a:extLst>
+          </a:blip>
+          <a:srcRect/>
+          <a:stretch>
+            <a:fillRect/>
+          </a:stretch>
+        </p:blipFill>
+        <p:spPr bwMode="auto">
+          <a:xfrm>
+            <a:off x="8912035" y="178961"/>
+            <a:ext cx="1744679" cy="589059"/>
+          </a:xfrm>
+          <a:prstGeom prst="rect">
+            <a:avLst/>
+          </a:prstGeom>
+          <a:noFill/>
+          <a:extLst>
+            <a:ext uri="{909E8E84-426E-40DD-AFC4-6F175D3DCCD1}">
+              <a14:hiddenFill xmlns:a14="http://schemas.microsoft.com/office/drawing/2010/main">
+                <a:solidFill>
+                  <a:srgbClr val="FFFFFF"/>
+                </a:solidFill>
+              </a14:hiddenFill>
+            </a:ext>
+          </a:extLst>
+        </p:spPr>
+      </p:pic>
+      <p:sp>
+        <p:nvSpPr>
+          <p:cNvPr id="2" name="Title 1">
+            <a:extLst>
+              <a:ext uri="{FF2B5EF4-FFF2-40B4-BE49-F238E27FC236}">
+                <a16:creationId xmlns:a16="http://schemas.microsoft.com/office/drawing/2014/main" id="{FD46D566-C938-7060-754A-771723D64592}"/>
+              </a:ext>
+            </a:extLst>
+          </p:cNvPr>
+          <p:cNvSpPr>
+            <a:spLocks noGrp="1"/>
+          </p:cNvSpPr>
+          <p:nvPr>
+            <p:ph type="title"/>
+          </p:nvPr>
+        </p:nvSpPr>
+        <p:spPr>
+          <a:xfrm>
+            <a:off x="881435" y="1249837"/>
+            <a:ext cx="10515600" cy="431326"/>
+          </a:xfrm>
+        </p:spPr>
+        <p:txBody>
+          <a:bodyPr>
+            <a:normAutofit fontScale="90000"/>
+          </a:bodyPr>
+          <a:lstStyle/>
+          <a:p>
+            <a:r>
+              <a:rPr lang="en-GB" dirty="0">
+                <a:solidFill>
+                  <a:schemeClr val="tx2"/>
+                </a:solidFill>
+              </a:rPr>
+              <a:t>Challenges</a:t>
+            </a:r>
+          </a:p>
+        </p:txBody>
+      </p:sp>
+    </p:spTree>
+    <p:extLst>
+      <p:ext uri="{BB962C8B-B14F-4D97-AF65-F5344CB8AC3E}">
+        <p14:creationId xmlns:p14="http://schemas.microsoft.com/office/powerpoint/2010/main" val="3614899595"/>
+      </p:ext>
+    </p:extLst>
+  </p:cSld>
+  <p:clrMapOvr>
+    <a:masterClrMapping/>
+  </p:clrMapOvr>
+</p:sld>
+</file>
+
+<file path=ppt/slides/slide18.xml><?xml version="1.0" encoding="utf-8"?>
+<p:sld xmlns:a="http://schemas.openxmlformats.org/drawingml/2006/main" xmlns:r="http://schemas.openxmlformats.org/officeDocument/2006/relationships" xmlns:p="http://schemas.openxmlformats.org/presentationml/2006/main">
+  <p:cSld>
+    <p:spTree>
+      <p:nvGrpSpPr>
+        <p:cNvPr id="1" name="">
+          <a:extLst>
+            <a:ext uri="{FF2B5EF4-FFF2-40B4-BE49-F238E27FC236}">
+              <a16:creationId xmlns:a16="http://schemas.microsoft.com/office/drawing/2014/main" id="{582896AD-A8C3-C65F-A512-7EE4A77B3F30}"/>
+            </a:ext>
+          </a:extLst>
+        </p:cNvPr>
+        <p:cNvGrpSpPr/>
+        <p:nvPr/>
+      </p:nvGrpSpPr>
+      <p:grpSpPr>
+        <a:xfrm>
+          <a:off x="0" y="0"/>
+          <a:ext cx="0" cy="0"/>
+          <a:chOff x="0" y="0"/>
+          <a:chExt cx="0" cy="0"/>
+        </a:xfrm>
+      </p:grpSpPr>
+      <p:cxnSp>
+        <p:nvCxnSpPr>
+          <p:cNvPr id="4" name="Straight Connector 3">
+            <a:extLst>
+              <a:ext uri="{FF2B5EF4-FFF2-40B4-BE49-F238E27FC236}">
+                <a16:creationId xmlns:a16="http://schemas.microsoft.com/office/drawing/2014/main" id="{A2691B0B-7C9E-58E0-11D0-BC8F43031D25}"/>
+              </a:ext>
+            </a:extLst>
+          </p:cNvPr>
+          <p:cNvCxnSpPr>
+            <a:cxnSpLocks/>
+          </p:cNvCxnSpPr>
+          <p:nvPr/>
+        </p:nvCxnSpPr>
+        <p:spPr>
+          <a:xfrm>
+            <a:off x="399700" y="894492"/>
+            <a:ext cx="11361770" cy="0"/>
+          </a:xfrm>
+          <a:prstGeom prst="line">
+            <a:avLst/>
+          </a:prstGeom>
+          <a:ln w="38100">
+            <a:solidFill>
+              <a:srgbClr val="237194"/>
+            </a:solidFill>
+          </a:ln>
+        </p:spPr>
+        <p:style>
+          <a:lnRef idx="2">
+            <a:schemeClr val="accent6"/>
+          </a:lnRef>
+          <a:fillRef idx="0">
+            <a:schemeClr val="accent6"/>
+          </a:fillRef>
+          <a:effectRef idx="1">
+            <a:schemeClr val="accent6"/>
+          </a:effectRef>
+          <a:fontRef idx="minor">
+            <a:schemeClr val="tx1"/>
+          </a:fontRef>
+        </p:style>
+      </p:cxnSp>
+      <p:sp>
+        <p:nvSpPr>
+          <p:cNvPr id="5" name="Title 1">
+            <a:extLst>
+              <a:ext uri="{FF2B5EF4-FFF2-40B4-BE49-F238E27FC236}">
+                <a16:creationId xmlns:a16="http://schemas.microsoft.com/office/drawing/2014/main" id="{6C86EC11-49B1-9FE9-9A7A-7ED178AE43C1}"/>
+              </a:ext>
+            </a:extLst>
+          </p:cNvPr>
+          <p:cNvSpPr txBox="1">
+            <a:spLocks/>
+          </p:cNvSpPr>
+          <p:nvPr/>
+        </p:nvSpPr>
+        <p:spPr>
+          <a:xfrm>
+            <a:off x="284498" y="83955"/>
+            <a:ext cx="11616350" cy="738664"/>
+          </a:xfrm>
+          <a:prstGeom prst="rect">
+            <a:avLst/>
+          </a:prstGeom>
+        </p:spPr>
+        <p:txBody>
+          <a:bodyPr vert="horz" wrap="square" lIns="91440" tIns="91440" rIns="91440" bIns="91440" rtlCol="0" anchor="b" anchorCtr="0">
+            <a:spAutoFit/>
+          </a:bodyPr>
+          <a:lstStyle>
+            <a:lvl1pPr algn="l" defTabSz="699614" rtl="0" eaLnBrk="1" latinLnBrk="0" hangingPunct="1">
+              <a:spcBef>
+                <a:spcPct val="0"/>
+              </a:spcBef>
+              <a:buNone/>
+              <a:defRPr sz="5400" b="0" i="0" kern="1200">
+                <a:solidFill>
+                  <a:schemeClr val="tx2"/>
+                </a:solidFill>
+                <a:latin typeface="Vitesse Light" charset="0"/>
+                <a:ea typeface="Vitesse Light" charset="0"/>
+                <a:cs typeface="Vitesse Light" charset="0"/>
+              </a:defRPr>
+            </a:lvl1pPr>
+          </a:lstStyle>
+          <a:p>
+            <a:r>
+              <a:rPr lang="es-ES" sz="3600" dirty="0" err="1">
+                <a:solidFill>
+                  <a:schemeClr val="tx1"/>
+                </a:solidFill>
+              </a:rPr>
+              <a:t>Transition</a:t>
+            </a:r>
+            <a:r>
+              <a:rPr lang="es-ES" sz="3600" dirty="0">
+                <a:solidFill>
+                  <a:schemeClr val="tx1"/>
+                </a:solidFill>
+              </a:rPr>
+              <a:t> metal complexes </a:t>
+            </a:r>
+            <a:r>
+              <a:rPr lang="en-US" sz="3600" dirty="0">
+                <a:solidFill>
+                  <a:schemeClr val="tx1"/>
+                </a:solidFill>
+              </a:rPr>
+              <a:t>SMILES</a:t>
+            </a:r>
+            <a:endParaRPr lang="es-ES" sz="3600" dirty="0">
+              <a:solidFill>
+                <a:schemeClr val="tx1"/>
+              </a:solidFill>
+            </a:endParaRPr>
+          </a:p>
+        </p:txBody>
+      </p:sp>
+      <p:pic>
+        <p:nvPicPr>
+          <p:cNvPr id="6" name="Picture 5" descr="A picture containing arrow&#10;&#10;Description automatically generated">
+            <a:extLst>
+              <a:ext uri="{FF2B5EF4-FFF2-40B4-BE49-F238E27FC236}">
+                <a16:creationId xmlns:a16="http://schemas.microsoft.com/office/drawing/2014/main" id="{BB05D7FF-51D0-D299-A9EE-FE408874B42C}"/>
+              </a:ext>
+            </a:extLst>
+          </p:cNvPr>
+          <p:cNvPicPr>
+            <a:picLocks noChangeAspect="1"/>
+          </p:cNvPicPr>
+          <p:nvPr/>
+        </p:nvPicPr>
+        <p:blipFill>
+          <a:blip r:embed="rId3"/>
+          <a:stretch>
+            <a:fillRect/>
+          </a:stretch>
+        </p:blipFill>
+        <p:spPr>
+          <a:xfrm>
+            <a:off x="10787654" y="13477"/>
+            <a:ext cx="1244134" cy="830042"/>
+          </a:xfrm>
+          <a:prstGeom prst="rect">
+            <a:avLst/>
+          </a:prstGeom>
+        </p:spPr>
+      </p:pic>
+      <p:pic>
+        <p:nvPicPr>
+          <p:cNvPr id="9" name="Picture 8" descr="IUI Mixto de Síntesis Química y Catálisis Homogenea (ISQCH) | Universidad  de Zaragoza">
+            <a:extLst>
+              <a:ext uri="{FF2B5EF4-FFF2-40B4-BE49-F238E27FC236}">
+                <a16:creationId xmlns:a16="http://schemas.microsoft.com/office/drawing/2014/main" id="{A6E22BF4-73E8-C12C-9A00-96E92F39476B}"/>
+              </a:ext>
+            </a:extLst>
+          </p:cNvPr>
+          <p:cNvPicPr>
+            <a:picLocks noChangeAspect="1" noChangeArrowheads="1"/>
+          </p:cNvPicPr>
+          <p:nvPr/>
+        </p:nvPicPr>
+        <p:blipFill>
+          <a:blip r:embed="rId4">
+            <a:extLst>
+              <a:ext uri="{28A0092B-C50C-407E-A947-70E740481C1C}">
+                <a14:useLocalDpi xmlns:a14="http://schemas.microsoft.com/office/drawing/2010/main" val="0"/>
+              </a:ext>
+            </a:extLst>
+          </a:blip>
+          <a:srcRect/>
+          <a:stretch>
+            <a:fillRect/>
+          </a:stretch>
+        </p:blipFill>
+        <p:spPr bwMode="auto">
+          <a:xfrm>
+            <a:off x="8912035" y="178961"/>
+            <a:ext cx="1744679" cy="589059"/>
+          </a:xfrm>
+          <a:prstGeom prst="rect">
+            <a:avLst/>
+          </a:prstGeom>
+          <a:noFill/>
+          <a:extLst>
+            <a:ext uri="{909E8E84-426E-40DD-AFC4-6F175D3DCCD1}">
+              <a14:hiddenFill xmlns:a14="http://schemas.microsoft.com/office/drawing/2010/main">
+                <a:solidFill>
+                  <a:srgbClr val="FFFFFF"/>
+                </a:solidFill>
+              </a14:hiddenFill>
+            </a:ext>
+          </a:extLst>
+        </p:spPr>
+      </p:pic>
+      <p:sp>
+        <p:nvSpPr>
+          <p:cNvPr id="2" name="Title 1">
+            <a:extLst>
+              <a:ext uri="{FF2B5EF4-FFF2-40B4-BE49-F238E27FC236}">
+                <a16:creationId xmlns:a16="http://schemas.microsoft.com/office/drawing/2014/main" id="{B2C5E9F0-7524-8835-4311-7DB118D7B626}"/>
+              </a:ext>
+            </a:extLst>
+          </p:cNvPr>
+          <p:cNvSpPr>
+            <a:spLocks noGrp="1"/>
+          </p:cNvSpPr>
+          <p:nvPr>
+            <p:ph type="title"/>
+          </p:nvPr>
+        </p:nvSpPr>
+        <p:spPr>
+          <a:xfrm>
+            <a:off x="881435" y="1249837"/>
+            <a:ext cx="10515600" cy="431326"/>
+          </a:xfrm>
+        </p:spPr>
+        <p:txBody>
+          <a:bodyPr>
+            <a:normAutofit fontScale="90000"/>
+          </a:bodyPr>
+          <a:lstStyle/>
+          <a:p>
+            <a:r>
+              <a:rPr lang="en-GB" dirty="0">
+                <a:solidFill>
+                  <a:schemeClr val="tx2"/>
+                </a:solidFill>
+              </a:rPr>
+              <a:t>Challenges</a:t>
+            </a:r>
+          </a:p>
+        </p:txBody>
+      </p:sp>
+      <p:sp>
+        <p:nvSpPr>
+          <p:cNvPr id="3" name="TextBox 2">
+            <a:extLst>
+              <a:ext uri="{FF2B5EF4-FFF2-40B4-BE49-F238E27FC236}">
+                <a16:creationId xmlns:a16="http://schemas.microsoft.com/office/drawing/2014/main" id="{20CA130D-E5D9-F2FD-E56E-31ADDC30421E}"/>
+              </a:ext>
+            </a:extLst>
+          </p:cNvPr>
+          <p:cNvSpPr txBox="1"/>
+          <p:nvPr/>
+        </p:nvSpPr>
+        <p:spPr>
+          <a:xfrm>
+            <a:off x="1240251" y="2042437"/>
+            <a:ext cx="10144108" cy="400110"/>
+          </a:xfrm>
+          <a:prstGeom prst="rect">
+            <a:avLst/>
+          </a:prstGeom>
+          <a:noFill/>
+        </p:spPr>
+        <p:txBody>
+          <a:bodyPr wrap="square">
+            <a:spAutoFit/>
+          </a:bodyPr>
+          <a:lstStyle/>
+          <a:p>
+            <a:pPr marL="0" indent="0">
+              <a:buNone/>
+            </a:pPr>
+            <a:r>
+              <a:rPr lang="es-ES" sz="2000" b="1" dirty="0"/>
+              <a:t>Machine-</a:t>
+            </a:r>
+            <a:r>
+              <a:rPr lang="es-ES" sz="2000" b="1" dirty="0" err="1"/>
+              <a:t>readable</a:t>
+            </a:r>
+            <a:r>
+              <a:rPr lang="es-ES" sz="2000" b="1" dirty="0"/>
+              <a:t> </a:t>
+            </a:r>
+            <a:r>
+              <a:rPr lang="es-ES" sz="2000" b="1" dirty="0" err="1"/>
+              <a:t>object</a:t>
+            </a:r>
+            <a:r>
+              <a:rPr lang="es-ES" sz="2000" dirty="0"/>
+              <a:t> metal-</a:t>
+            </a:r>
+            <a:r>
+              <a:rPr lang="es-ES" sz="2000" dirty="0" err="1"/>
+              <a:t>containing</a:t>
+            </a:r>
+            <a:r>
+              <a:rPr lang="es-ES" sz="2000" dirty="0"/>
+              <a:t> </a:t>
+            </a:r>
+            <a:r>
+              <a:rPr lang="es-ES" sz="2000" dirty="0" err="1"/>
+              <a:t>compound</a:t>
+            </a:r>
+            <a:r>
+              <a:rPr lang="es-ES" sz="2000" dirty="0"/>
+              <a:t>: no </a:t>
+            </a:r>
+            <a:r>
+              <a:rPr lang="es-ES" sz="2000" dirty="0" err="1"/>
+              <a:t>clear</a:t>
+            </a:r>
+            <a:r>
+              <a:rPr lang="es-ES" sz="2000" dirty="0"/>
+              <a:t> bond </a:t>
+            </a:r>
+            <a:r>
+              <a:rPr lang="es-ES" sz="2000" dirty="0" err="1"/>
+              <a:t>definitions</a:t>
+            </a:r>
+            <a:r>
+              <a:rPr lang="es-ES" sz="2000" dirty="0"/>
+              <a:t> </a:t>
+            </a:r>
+            <a:endParaRPr lang="en-GB" sz="2000" dirty="0"/>
+          </a:p>
+        </p:txBody>
+      </p:sp>
+      <p:grpSp>
+        <p:nvGrpSpPr>
+          <p:cNvPr id="11" name="Group 10">
+            <a:extLst>
+              <a:ext uri="{FF2B5EF4-FFF2-40B4-BE49-F238E27FC236}">
+                <a16:creationId xmlns:a16="http://schemas.microsoft.com/office/drawing/2014/main" id="{0863FF57-61C3-094A-5D11-A8756CC9A81D}"/>
+              </a:ext>
+            </a:extLst>
+          </p:cNvPr>
+          <p:cNvGrpSpPr/>
+          <p:nvPr/>
+        </p:nvGrpSpPr>
+        <p:grpSpPr>
+          <a:xfrm>
+            <a:off x="701435" y="2040063"/>
+            <a:ext cx="360000" cy="400110"/>
+            <a:chOff x="658200" y="1058988"/>
+            <a:chExt cx="360000" cy="400110"/>
+          </a:xfrm>
+        </p:grpSpPr>
+        <p:sp>
+          <p:nvSpPr>
+            <p:cNvPr id="12" name="Rectangle: Rounded Corners 11">
+              <a:extLst>
+                <a:ext uri="{FF2B5EF4-FFF2-40B4-BE49-F238E27FC236}">
+                  <a16:creationId xmlns:a16="http://schemas.microsoft.com/office/drawing/2014/main" id="{BE203E58-91F5-8EB4-7182-1927094790BF}"/>
+                </a:ext>
+              </a:extLst>
+            </p:cNvPr>
+            <p:cNvSpPr/>
+            <p:nvPr/>
+          </p:nvSpPr>
+          <p:spPr>
+            <a:xfrm>
+              <a:off x="658200" y="1079043"/>
+              <a:ext cx="360000" cy="360000"/>
+            </a:xfrm>
+            <a:prstGeom prst="roundRect">
+              <a:avLst/>
+            </a:prstGeom>
+            <a:solidFill>
+              <a:schemeClr val="accent3">
+                <a:lumMod val="20000"/>
+                <a:lumOff val="80000"/>
+              </a:schemeClr>
+            </a:solidFill>
+            <a:ln>
+              <a:noFill/>
+            </a:ln>
+          </p:spPr>
+          <p:style>
+            <a:lnRef idx="2">
+              <a:schemeClr val="accent1">
+                <a:shade val="15000"/>
+              </a:schemeClr>
+            </a:lnRef>
+            <a:fillRef idx="1">
+              <a:schemeClr val="accent1"/>
+            </a:fillRef>
+            <a:effectRef idx="0">
+              <a:schemeClr val="accent1"/>
+            </a:effectRef>
+            <a:fontRef idx="minor">
+              <a:schemeClr val="lt1"/>
+            </a:fontRef>
+          </p:style>
+          <p:txBody>
+            <a:bodyPr rtlCol="0" anchor="ctr"/>
+            <a:lstStyle/>
+            <a:p>
+              <a:pPr algn="ctr"/>
+              <a:endParaRPr lang="en-GB" dirty="0"/>
+            </a:p>
+          </p:txBody>
+        </p:sp>
+        <p:sp>
+          <p:nvSpPr>
+            <p:cNvPr id="13" name="TextBox 12">
+              <a:extLst>
+                <a:ext uri="{FF2B5EF4-FFF2-40B4-BE49-F238E27FC236}">
+                  <a16:creationId xmlns:a16="http://schemas.microsoft.com/office/drawing/2014/main" id="{583DBE53-C50E-EEEB-8A92-847A8715CA69}"/>
+                </a:ext>
+              </a:extLst>
+            </p:cNvPr>
+            <p:cNvSpPr txBox="1"/>
+            <p:nvPr/>
+          </p:nvSpPr>
+          <p:spPr>
+            <a:xfrm>
+              <a:off x="697253" y="1058988"/>
+              <a:ext cx="281894" cy="400110"/>
+            </a:xfrm>
+            <a:prstGeom prst="rect">
+              <a:avLst/>
+            </a:prstGeom>
+            <a:noFill/>
+          </p:spPr>
+          <p:txBody>
+            <a:bodyPr wrap="square">
+              <a:spAutoFit/>
+            </a:bodyPr>
+            <a:lstStyle/>
+            <a:p>
+              <a:r>
+                <a:rPr lang="es-ES" sz="2000" b="1" dirty="0"/>
+                <a:t>!</a:t>
+              </a:r>
+            </a:p>
+          </p:txBody>
+        </p:sp>
+      </p:grpSp>
+      <p:pic>
+        <p:nvPicPr>
+          <p:cNvPr id="23" name="Picture 22">
+            <a:extLst>
+              <a:ext uri="{FF2B5EF4-FFF2-40B4-BE49-F238E27FC236}">
+                <a16:creationId xmlns:a16="http://schemas.microsoft.com/office/drawing/2014/main" id="{4BBF8AED-1A0A-C0F1-FCC3-256327C3F13C}"/>
+              </a:ext>
+            </a:extLst>
+          </p:cNvPr>
+          <p:cNvPicPr>
+            <a:picLocks noChangeAspect="1"/>
+          </p:cNvPicPr>
+          <p:nvPr/>
+        </p:nvPicPr>
+        <p:blipFill>
+          <a:blip r:embed="rId5"/>
+          <a:srcRect b="57092"/>
+          <a:stretch>
+            <a:fillRect/>
+          </a:stretch>
+        </p:blipFill>
+        <p:spPr>
+          <a:xfrm>
+            <a:off x="1449291" y="2865529"/>
+            <a:ext cx="4013362" cy="1544546"/>
+          </a:xfrm>
+          <a:prstGeom prst="rect">
+            <a:avLst/>
+          </a:prstGeom>
+        </p:spPr>
+      </p:pic>
+      <p:pic>
+        <p:nvPicPr>
+          <p:cNvPr id="24" name="Picture 23">
+            <a:extLst>
+              <a:ext uri="{FF2B5EF4-FFF2-40B4-BE49-F238E27FC236}">
+                <a16:creationId xmlns:a16="http://schemas.microsoft.com/office/drawing/2014/main" id="{701B90B4-3AB8-F9E0-FEE4-E5E34649AB6F}"/>
+              </a:ext>
+            </a:extLst>
+          </p:cNvPr>
+          <p:cNvPicPr>
+            <a:picLocks noChangeAspect="1"/>
+          </p:cNvPicPr>
+          <p:nvPr/>
+        </p:nvPicPr>
+        <p:blipFill>
+          <a:blip r:embed="rId5"/>
+          <a:srcRect t="40781" b="-1311"/>
+          <a:stretch>
+            <a:fillRect/>
+          </a:stretch>
+        </p:blipFill>
+        <p:spPr>
+          <a:xfrm>
+            <a:off x="6102723" y="2703569"/>
+            <a:ext cx="3675283" cy="1995333"/>
+          </a:xfrm>
+          <a:prstGeom prst="rect">
+            <a:avLst/>
+          </a:prstGeom>
+        </p:spPr>
+      </p:pic>
+      <p:pic>
+        <p:nvPicPr>
+          <p:cNvPr id="25" name="Picture 24">
+            <a:extLst>
+              <a:ext uri="{FF2B5EF4-FFF2-40B4-BE49-F238E27FC236}">
+                <a16:creationId xmlns:a16="http://schemas.microsoft.com/office/drawing/2014/main" id="{2E7FA861-1778-55C7-DE0F-851D62A8108C}"/>
+              </a:ext>
+            </a:extLst>
+          </p:cNvPr>
+          <p:cNvPicPr>
+            <a:picLocks noChangeAspect="1"/>
+          </p:cNvPicPr>
+          <p:nvPr/>
+        </p:nvPicPr>
+        <p:blipFill>
+          <a:blip r:embed="rId5"/>
+          <a:srcRect b="92713"/>
+          <a:stretch>
+            <a:fillRect/>
+          </a:stretch>
+        </p:blipFill>
+        <p:spPr>
+          <a:xfrm>
+            <a:off x="5818266" y="2503539"/>
+            <a:ext cx="4013362" cy="262293"/>
+          </a:xfrm>
+          <a:prstGeom prst="rect">
+            <a:avLst/>
+          </a:prstGeom>
+        </p:spPr>
+      </p:pic>
+    </p:spTree>
+    <p:extLst>
+      <p:ext uri="{BB962C8B-B14F-4D97-AF65-F5344CB8AC3E}">
+        <p14:creationId xmlns:p14="http://schemas.microsoft.com/office/powerpoint/2010/main" val="3936666425"/>
+      </p:ext>
+    </p:extLst>
+  </p:cSld>
+  <p:clrMapOvr>
+    <a:masterClrMapping/>
+  </p:clrMapOvr>
+</p:sld>
+</file>
+
+<file path=ppt/slides/slide19.xml><?xml version="1.0" encoding="utf-8"?>
+<p:sld xmlns:a="http://schemas.openxmlformats.org/drawingml/2006/main" xmlns:r="http://schemas.openxmlformats.org/officeDocument/2006/relationships" xmlns:p="http://schemas.openxmlformats.org/presentationml/2006/main">
+  <p:cSld>
+    <p:spTree>
+      <p:nvGrpSpPr>
+        <p:cNvPr id="1" name="">
+          <a:extLst>
+            <a:ext uri="{FF2B5EF4-FFF2-40B4-BE49-F238E27FC236}">
+              <a16:creationId xmlns:a16="http://schemas.microsoft.com/office/drawing/2014/main" id="{51B371A2-1F3E-7D69-74DF-C193207DFECE}"/>
+            </a:ext>
+          </a:extLst>
+        </p:cNvPr>
+        <p:cNvGrpSpPr/>
+        <p:nvPr/>
+      </p:nvGrpSpPr>
+      <p:grpSpPr>
+        <a:xfrm>
+          <a:off x="0" y="0"/>
+          <a:ext cx="0" cy="0"/>
+          <a:chOff x="0" y="0"/>
+          <a:chExt cx="0" cy="0"/>
+        </a:xfrm>
+      </p:grpSpPr>
+      <p:cxnSp>
+        <p:nvCxnSpPr>
+          <p:cNvPr id="4" name="Straight Connector 3">
+            <a:extLst>
+              <a:ext uri="{FF2B5EF4-FFF2-40B4-BE49-F238E27FC236}">
+                <a16:creationId xmlns:a16="http://schemas.microsoft.com/office/drawing/2014/main" id="{C97EEC95-7C65-4504-08D7-1F84F3324300}"/>
+              </a:ext>
+            </a:extLst>
+          </p:cNvPr>
+          <p:cNvCxnSpPr>
+            <a:cxnSpLocks/>
+          </p:cNvCxnSpPr>
+          <p:nvPr/>
+        </p:nvCxnSpPr>
+        <p:spPr>
+          <a:xfrm>
+            <a:off x="399700" y="894492"/>
+            <a:ext cx="11361770" cy="0"/>
+          </a:xfrm>
+          <a:prstGeom prst="line">
+            <a:avLst/>
+          </a:prstGeom>
+          <a:ln w="38100">
+            <a:solidFill>
+              <a:srgbClr val="237194"/>
+            </a:solidFill>
+          </a:ln>
+        </p:spPr>
+        <p:style>
+          <a:lnRef idx="2">
+            <a:schemeClr val="accent6"/>
+          </a:lnRef>
+          <a:fillRef idx="0">
+            <a:schemeClr val="accent6"/>
+          </a:fillRef>
+          <a:effectRef idx="1">
+            <a:schemeClr val="accent6"/>
+          </a:effectRef>
+          <a:fontRef idx="minor">
+            <a:schemeClr val="tx1"/>
+          </a:fontRef>
+        </p:style>
+      </p:cxnSp>
+      <p:sp>
+        <p:nvSpPr>
+          <p:cNvPr id="5" name="Title 1">
+            <a:extLst>
+              <a:ext uri="{FF2B5EF4-FFF2-40B4-BE49-F238E27FC236}">
+                <a16:creationId xmlns:a16="http://schemas.microsoft.com/office/drawing/2014/main" id="{2407194F-4C98-930D-44FA-080B5F5F9882}"/>
+              </a:ext>
+            </a:extLst>
+          </p:cNvPr>
+          <p:cNvSpPr txBox="1">
+            <a:spLocks/>
+          </p:cNvSpPr>
+          <p:nvPr/>
+        </p:nvSpPr>
+        <p:spPr>
+          <a:xfrm>
+            <a:off x="284498" y="83955"/>
+            <a:ext cx="11616350" cy="738664"/>
+          </a:xfrm>
+          <a:prstGeom prst="rect">
+            <a:avLst/>
+          </a:prstGeom>
+        </p:spPr>
+        <p:txBody>
+          <a:bodyPr vert="horz" wrap="square" lIns="91440" tIns="91440" rIns="91440" bIns="91440" rtlCol="0" anchor="b" anchorCtr="0">
+            <a:spAutoFit/>
+          </a:bodyPr>
+          <a:lstStyle>
+            <a:lvl1pPr algn="l" defTabSz="699614" rtl="0" eaLnBrk="1" latinLnBrk="0" hangingPunct="1">
+              <a:spcBef>
+                <a:spcPct val="0"/>
+              </a:spcBef>
+              <a:buNone/>
+              <a:defRPr sz="5400" b="0" i="0" kern="1200">
+                <a:solidFill>
+                  <a:schemeClr val="tx2"/>
+                </a:solidFill>
+                <a:latin typeface="Vitesse Light" charset="0"/>
+                <a:ea typeface="Vitesse Light" charset="0"/>
+                <a:cs typeface="Vitesse Light" charset="0"/>
+              </a:defRPr>
+            </a:lvl1pPr>
+          </a:lstStyle>
+          <a:p>
+            <a:r>
+              <a:rPr lang="es-ES" sz="3600" dirty="0" err="1">
+                <a:solidFill>
+                  <a:schemeClr val="tx1"/>
+                </a:solidFill>
+              </a:rPr>
+              <a:t>Transition</a:t>
+            </a:r>
+            <a:r>
+              <a:rPr lang="es-ES" sz="3600" dirty="0">
+                <a:solidFill>
+                  <a:schemeClr val="tx1"/>
+                </a:solidFill>
+              </a:rPr>
+              <a:t> metal complexes </a:t>
+            </a:r>
+            <a:r>
+              <a:rPr lang="en-US" sz="3600" dirty="0">
+                <a:solidFill>
+                  <a:schemeClr val="tx1"/>
+                </a:solidFill>
+              </a:rPr>
+              <a:t>SMILES</a:t>
+            </a:r>
+            <a:endParaRPr lang="es-ES" sz="3600" dirty="0">
+              <a:solidFill>
+                <a:schemeClr val="tx1"/>
+              </a:solidFill>
+            </a:endParaRPr>
+          </a:p>
+        </p:txBody>
+      </p:sp>
+      <p:pic>
+        <p:nvPicPr>
+          <p:cNvPr id="6" name="Picture 5" descr="A picture containing arrow&#10;&#10;Description automatically generated">
+            <a:extLst>
+              <a:ext uri="{FF2B5EF4-FFF2-40B4-BE49-F238E27FC236}">
+                <a16:creationId xmlns:a16="http://schemas.microsoft.com/office/drawing/2014/main" id="{BFE619A8-C7B5-550F-48FC-A88B8B9B9FAE}"/>
+              </a:ext>
+            </a:extLst>
+          </p:cNvPr>
+          <p:cNvPicPr>
+            <a:picLocks noChangeAspect="1"/>
+          </p:cNvPicPr>
+          <p:nvPr/>
+        </p:nvPicPr>
+        <p:blipFill>
+          <a:blip r:embed="rId3"/>
+          <a:stretch>
+            <a:fillRect/>
+          </a:stretch>
+        </p:blipFill>
+        <p:spPr>
+          <a:xfrm>
+            <a:off x="10787654" y="13477"/>
+            <a:ext cx="1244134" cy="830042"/>
+          </a:xfrm>
+          <a:prstGeom prst="rect">
+            <a:avLst/>
+          </a:prstGeom>
+        </p:spPr>
+      </p:pic>
+      <p:pic>
+        <p:nvPicPr>
+          <p:cNvPr id="9" name="Picture 8" descr="IUI Mixto de Síntesis Química y Catálisis Homogenea (ISQCH) | Universidad  de Zaragoza">
+            <a:extLst>
+              <a:ext uri="{FF2B5EF4-FFF2-40B4-BE49-F238E27FC236}">
+                <a16:creationId xmlns:a16="http://schemas.microsoft.com/office/drawing/2014/main" id="{E0DD93B4-8930-0148-AEA9-456E6D8217CC}"/>
+              </a:ext>
+            </a:extLst>
+          </p:cNvPr>
+          <p:cNvPicPr>
+            <a:picLocks noChangeAspect="1" noChangeArrowheads="1"/>
+          </p:cNvPicPr>
+          <p:nvPr/>
+        </p:nvPicPr>
+        <p:blipFill>
+          <a:blip r:embed="rId4">
+            <a:extLst>
+              <a:ext uri="{28A0092B-C50C-407E-A947-70E740481C1C}">
+                <a14:useLocalDpi xmlns:a14="http://schemas.microsoft.com/office/drawing/2010/main" val="0"/>
+              </a:ext>
+            </a:extLst>
+          </a:blip>
+          <a:srcRect/>
+          <a:stretch>
+            <a:fillRect/>
+          </a:stretch>
+        </p:blipFill>
+        <p:spPr bwMode="auto">
+          <a:xfrm>
+            <a:off x="8912035" y="178961"/>
+            <a:ext cx="1744679" cy="589059"/>
+          </a:xfrm>
+          <a:prstGeom prst="rect">
+            <a:avLst/>
+          </a:prstGeom>
+          <a:noFill/>
+          <a:extLst>
+            <a:ext uri="{909E8E84-426E-40DD-AFC4-6F175D3DCCD1}">
+              <a14:hiddenFill xmlns:a14="http://schemas.microsoft.com/office/drawing/2010/main">
+                <a:solidFill>
+                  <a:srgbClr val="FFFFFF"/>
+                </a:solidFill>
+              </a14:hiddenFill>
+            </a:ext>
+          </a:extLst>
+        </p:spPr>
+      </p:pic>
+      <p:sp>
+        <p:nvSpPr>
+          <p:cNvPr id="2" name="Title 1">
+            <a:extLst>
+              <a:ext uri="{FF2B5EF4-FFF2-40B4-BE49-F238E27FC236}">
+                <a16:creationId xmlns:a16="http://schemas.microsoft.com/office/drawing/2014/main" id="{5B3E29C9-7BE3-C978-FD86-9DC792D25AEE}"/>
+              </a:ext>
+            </a:extLst>
+          </p:cNvPr>
+          <p:cNvSpPr>
+            <a:spLocks noGrp="1"/>
+          </p:cNvSpPr>
+          <p:nvPr>
+            <p:ph type="title"/>
+          </p:nvPr>
+        </p:nvSpPr>
+        <p:spPr>
+          <a:xfrm>
+            <a:off x="881435" y="1249837"/>
+            <a:ext cx="10515600" cy="431326"/>
+          </a:xfrm>
+        </p:spPr>
+        <p:txBody>
+          <a:bodyPr>
+            <a:normAutofit fontScale="90000"/>
+          </a:bodyPr>
+          <a:lstStyle/>
+          <a:p>
+            <a:r>
+              <a:rPr lang="en-GB" dirty="0">
+                <a:solidFill>
+                  <a:schemeClr val="tx2"/>
+                </a:solidFill>
+              </a:rPr>
+              <a:t>Challenges</a:t>
+            </a:r>
+          </a:p>
+        </p:txBody>
+      </p:sp>
+      <p:sp>
+        <p:nvSpPr>
+          <p:cNvPr id="3" name="TextBox 2">
+            <a:extLst>
+              <a:ext uri="{FF2B5EF4-FFF2-40B4-BE49-F238E27FC236}">
+                <a16:creationId xmlns:a16="http://schemas.microsoft.com/office/drawing/2014/main" id="{5B399198-2B2A-ABB6-9595-0C134F12A3BD}"/>
+              </a:ext>
+            </a:extLst>
+          </p:cNvPr>
+          <p:cNvSpPr txBox="1"/>
+          <p:nvPr/>
+        </p:nvSpPr>
+        <p:spPr>
+          <a:xfrm>
+            <a:off x="1240251" y="2042437"/>
+            <a:ext cx="10144108" cy="400110"/>
+          </a:xfrm>
+          <a:prstGeom prst="rect">
+            <a:avLst/>
+          </a:prstGeom>
+          <a:noFill/>
+        </p:spPr>
+        <p:txBody>
+          <a:bodyPr wrap="square">
+            <a:spAutoFit/>
+          </a:bodyPr>
+          <a:lstStyle/>
+          <a:p>
+            <a:pPr marL="0" indent="0">
+              <a:buNone/>
+            </a:pPr>
+            <a:r>
+              <a:rPr lang="es-ES" sz="2000" b="1" dirty="0"/>
+              <a:t>Machine-</a:t>
+            </a:r>
+            <a:r>
+              <a:rPr lang="es-ES" sz="2000" b="1" dirty="0" err="1"/>
+              <a:t>readable</a:t>
+            </a:r>
+            <a:r>
+              <a:rPr lang="es-ES" sz="2000" b="1" dirty="0"/>
+              <a:t> </a:t>
+            </a:r>
+            <a:r>
+              <a:rPr lang="es-ES" sz="2000" b="1" dirty="0" err="1"/>
+              <a:t>object</a:t>
+            </a:r>
+            <a:r>
+              <a:rPr lang="es-ES" sz="2000" dirty="0"/>
+              <a:t> metal-</a:t>
+            </a:r>
+            <a:r>
+              <a:rPr lang="es-ES" sz="2000" dirty="0" err="1"/>
+              <a:t>containing</a:t>
+            </a:r>
+            <a:r>
+              <a:rPr lang="es-ES" sz="2000" dirty="0"/>
+              <a:t> </a:t>
+            </a:r>
+            <a:r>
+              <a:rPr lang="es-ES" sz="2000" dirty="0" err="1"/>
+              <a:t>compound</a:t>
+            </a:r>
+            <a:r>
+              <a:rPr lang="es-ES" sz="2000" dirty="0"/>
+              <a:t>: no </a:t>
+            </a:r>
+            <a:r>
+              <a:rPr lang="es-ES" sz="2000" dirty="0" err="1"/>
+              <a:t>clear</a:t>
+            </a:r>
+            <a:r>
+              <a:rPr lang="es-ES" sz="2000" dirty="0"/>
+              <a:t> bond </a:t>
+            </a:r>
+            <a:r>
+              <a:rPr lang="es-ES" sz="2000" dirty="0" err="1"/>
+              <a:t>definitions</a:t>
+            </a:r>
+            <a:r>
+              <a:rPr lang="es-ES" sz="2000" dirty="0"/>
+              <a:t> </a:t>
+            </a:r>
+            <a:endParaRPr lang="en-GB" sz="2000" dirty="0"/>
+          </a:p>
+        </p:txBody>
+      </p:sp>
+      <p:sp>
+        <p:nvSpPr>
+          <p:cNvPr id="7" name="TextBox 6">
+            <a:extLst>
+              <a:ext uri="{FF2B5EF4-FFF2-40B4-BE49-F238E27FC236}">
+                <a16:creationId xmlns:a16="http://schemas.microsoft.com/office/drawing/2014/main" id="{66699A4B-8A78-0F92-8891-20B10B6D52D5}"/>
+              </a:ext>
+            </a:extLst>
+          </p:cNvPr>
+          <p:cNvSpPr txBox="1"/>
+          <p:nvPr/>
+        </p:nvSpPr>
+        <p:spPr>
+          <a:xfrm>
+            <a:off x="1240251" y="4810065"/>
+            <a:ext cx="7505453" cy="400110"/>
+          </a:xfrm>
+          <a:prstGeom prst="rect">
+            <a:avLst/>
+          </a:prstGeom>
+          <a:noFill/>
+        </p:spPr>
+        <p:txBody>
+          <a:bodyPr wrap="square">
+            <a:spAutoFit/>
+          </a:bodyPr>
+          <a:lstStyle/>
+          <a:p>
+            <a:r>
+              <a:rPr lang="es-ES" sz="2000" b="1" dirty="0"/>
+              <a:t>QM</a:t>
+            </a:r>
+            <a:r>
+              <a:rPr lang="es-ES" sz="2000" dirty="0"/>
+              <a:t> </a:t>
+            </a:r>
+            <a:r>
+              <a:rPr lang="es-ES" sz="2000" dirty="0" err="1"/>
+              <a:t>accurate</a:t>
+            </a:r>
+            <a:r>
+              <a:rPr lang="es-ES" sz="2000" dirty="0"/>
+              <a:t> </a:t>
+            </a:r>
+            <a:r>
+              <a:rPr lang="es-ES" sz="2000" dirty="0" err="1"/>
+              <a:t>calculations</a:t>
+            </a:r>
+            <a:r>
+              <a:rPr lang="es-ES" sz="2000" dirty="0"/>
+              <a:t> are </a:t>
+            </a:r>
+            <a:r>
+              <a:rPr lang="es-ES" sz="2000" b="1" dirty="0" err="1"/>
+              <a:t>expensive</a:t>
+            </a:r>
+            <a:r>
+              <a:rPr lang="es-ES" sz="2000" dirty="0"/>
+              <a:t> </a:t>
+            </a:r>
+            <a:r>
+              <a:rPr lang="es-ES" sz="2000" dirty="0" err="1"/>
+              <a:t>with</a:t>
+            </a:r>
+            <a:r>
+              <a:rPr lang="es-ES" sz="2000" dirty="0"/>
+              <a:t> </a:t>
+            </a:r>
+            <a:r>
+              <a:rPr lang="es-ES" sz="2000" dirty="0" err="1"/>
+              <a:t>metals</a:t>
+            </a:r>
+            <a:r>
+              <a:rPr lang="es-ES" sz="2000" dirty="0"/>
+              <a:t> </a:t>
+            </a:r>
+          </a:p>
+        </p:txBody>
+      </p:sp>
+      <p:sp>
+        <p:nvSpPr>
+          <p:cNvPr id="8" name="TextBox 7">
+            <a:extLst>
+              <a:ext uri="{FF2B5EF4-FFF2-40B4-BE49-F238E27FC236}">
+                <a16:creationId xmlns:a16="http://schemas.microsoft.com/office/drawing/2014/main" id="{86DBD32A-2F00-DDD8-6945-06ED80B6C43C}"/>
+              </a:ext>
+            </a:extLst>
+          </p:cNvPr>
+          <p:cNvSpPr txBox="1"/>
+          <p:nvPr/>
+        </p:nvSpPr>
+        <p:spPr>
+          <a:xfrm>
+            <a:off x="1240251" y="5693519"/>
+            <a:ext cx="5872154" cy="400110"/>
+          </a:xfrm>
+          <a:prstGeom prst="rect">
+            <a:avLst/>
+          </a:prstGeom>
+          <a:noFill/>
+        </p:spPr>
+        <p:txBody>
+          <a:bodyPr wrap="square">
+            <a:spAutoFit/>
+          </a:bodyPr>
+          <a:lstStyle/>
+          <a:p>
+            <a:r>
+              <a:rPr lang="es-ES" sz="2000" dirty="0" err="1"/>
+              <a:t>Inconsistent</a:t>
+            </a:r>
+            <a:r>
+              <a:rPr lang="es-ES" sz="2000" dirty="0"/>
+              <a:t> </a:t>
+            </a:r>
+            <a:r>
+              <a:rPr lang="es-ES" sz="2000" dirty="0" err="1"/>
+              <a:t>formats</a:t>
+            </a:r>
+            <a:r>
+              <a:rPr lang="es-ES" sz="2000" dirty="0"/>
+              <a:t> </a:t>
+            </a:r>
+            <a:r>
+              <a:rPr lang="es-ES" sz="2000" dirty="0" err="1"/>
+              <a:t>across</a:t>
+            </a:r>
+            <a:r>
+              <a:rPr lang="es-ES" sz="2000" dirty="0"/>
+              <a:t> </a:t>
+            </a:r>
+            <a:r>
+              <a:rPr lang="es-ES" sz="2000" dirty="0" err="1"/>
+              <a:t>literature</a:t>
+            </a:r>
+            <a:r>
+              <a:rPr lang="es-ES" sz="2000" dirty="0"/>
+              <a:t> </a:t>
+            </a:r>
+          </a:p>
+        </p:txBody>
+      </p:sp>
+      <p:grpSp>
+        <p:nvGrpSpPr>
+          <p:cNvPr id="11" name="Group 10">
+            <a:extLst>
+              <a:ext uri="{FF2B5EF4-FFF2-40B4-BE49-F238E27FC236}">
+                <a16:creationId xmlns:a16="http://schemas.microsoft.com/office/drawing/2014/main" id="{75E990EE-6057-3FD9-267A-0414DFF87929}"/>
+              </a:ext>
+            </a:extLst>
+          </p:cNvPr>
+          <p:cNvGrpSpPr/>
+          <p:nvPr/>
+        </p:nvGrpSpPr>
+        <p:grpSpPr>
+          <a:xfrm>
+            <a:off x="701435" y="2040063"/>
+            <a:ext cx="360000" cy="400110"/>
+            <a:chOff x="658200" y="1058988"/>
+            <a:chExt cx="360000" cy="400110"/>
+          </a:xfrm>
+        </p:grpSpPr>
+        <p:sp>
+          <p:nvSpPr>
+            <p:cNvPr id="12" name="Rectangle: Rounded Corners 11">
+              <a:extLst>
+                <a:ext uri="{FF2B5EF4-FFF2-40B4-BE49-F238E27FC236}">
+                  <a16:creationId xmlns:a16="http://schemas.microsoft.com/office/drawing/2014/main" id="{BC6EEFB5-9663-3299-2E8E-D6A7AACCC3D8}"/>
+                </a:ext>
+              </a:extLst>
+            </p:cNvPr>
+            <p:cNvSpPr/>
+            <p:nvPr/>
+          </p:nvSpPr>
+          <p:spPr>
+            <a:xfrm>
+              <a:off x="658200" y="1079043"/>
+              <a:ext cx="360000" cy="360000"/>
+            </a:xfrm>
+            <a:prstGeom prst="roundRect">
+              <a:avLst/>
+            </a:prstGeom>
+            <a:solidFill>
+              <a:schemeClr val="accent3">
+                <a:lumMod val="20000"/>
+                <a:lumOff val="80000"/>
+              </a:schemeClr>
+            </a:solidFill>
+            <a:ln>
+              <a:noFill/>
+            </a:ln>
+          </p:spPr>
+          <p:style>
+            <a:lnRef idx="2">
+              <a:schemeClr val="accent1">
+                <a:shade val="15000"/>
+              </a:schemeClr>
+            </a:lnRef>
+            <a:fillRef idx="1">
+              <a:schemeClr val="accent1"/>
+            </a:fillRef>
+            <a:effectRef idx="0">
+              <a:schemeClr val="accent1"/>
+            </a:effectRef>
+            <a:fontRef idx="minor">
+              <a:schemeClr val="lt1"/>
+            </a:fontRef>
+          </p:style>
+          <p:txBody>
+            <a:bodyPr rtlCol="0" anchor="ctr"/>
+            <a:lstStyle/>
+            <a:p>
+              <a:pPr algn="ctr"/>
+              <a:endParaRPr lang="en-GB" dirty="0"/>
+            </a:p>
+          </p:txBody>
+        </p:sp>
+        <p:sp>
+          <p:nvSpPr>
+            <p:cNvPr id="13" name="TextBox 12">
+              <a:extLst>
+                <a:ext uri="{FF2B5EF4-FFF2-40B4-BE49-F238E27FC236}">
+                  <a16:creationId xmlns:a16="http://schemas.microsoft.com/office/drawing/2014/main" id="{4950D559-1AE0-8717-35A6-F04A63A37B03}"/>
+                </a:ext>
+              </a:extLst>
+            </p:cNvPr>
+            <p:cNvSpPr txBox="1"/>
+            <p:nvPr/>
+          </p:nvSpPr>
+          <p:spPr>
+            <a:xfrm>
+              <a:off x="697253" y="1058988"/>
+              <a:ext cx="281894" cy="400110"/>
+            </a:xfrm>
+            <a:prstGeom prst="rect">
+              <a:avLst/>
+            </a:prstGeom>
+            <a:noFill/>
+          </p:spPr>
+          <p:txBody>
+            <a:bodyPr wrap="square">
+              <a:spAutoFit/>
+            </a:bodyPr>
+            <a:lstStyle/>
+            <a:p>
+              <a:r>
+                <a:rPr lang="es-ES" sz="2000" b="1" dirty="0"/>
+                <a:t>!</a:t>
+              </a:r>
+            </a:p>
+          </p:txBody>
+        </p:sp>
+      </p:grpSp>
+      <p:grpSp>
+        <p:nvGrpSpPr>
+          <p:cNvPr id="14" name="Group 13">
+            <a:extLst>
+              <a:ext uri="{FF2B5EF4-FFF2-40B4-BE49-F238E27FC236}">
+                <a16:creationId xmlns:a16="http://schemas.microsoft.com/office/drawing/2014/main" id="{263C8AC5-B770-72E3-9CD1-71DB57AD69E5}"/>
+              </a:ext>
+            </a:extLst>
+          </p:cNvPr>
+          <p:cNvGrpSpPr/>
+          <p:nvPr/>
+        </p:nvGrpSpPr>
+        <p:grpSpPr>
+          <a:xfrm>
+            <a:off x="701435" y="4825458"/>
+            <a:ext cx="360000" cy="400110"/>
+            <a:chOff x="658200" y="1058988"/>
+            <a:chExt cx="360000" cy="400110"/>
+          </a:xfrm>
+        </p:grpSpPr>
+        <p:sp>
+          <p:nvSpPr>
+            <p:cNvPr id="15" name="Rectangle: Rounded Corners 14">
+              <a:extLst>
+                <a:ext uri="{FF2B5EF4-FFF2-40B4-BE49-F238E27FC236}">
+                  <a16:creationId xmlns:a16="http://schemas.microsoft.com/office/drawing/2014/main" id="{06A59DE0-9F3D-40F1-DD4D-B680C1F54293}"/>
+                </a:ext>
+              </a:extLst>
+            </p:cNvPr>
+            <p:cNvSpPr/>
+            <p:nvPr/>
+          </p:nvSpPr>
+          <p:spPr>
+            <a:xfrm>
+              <a:off x="658200" y="1079043"/>
+              <a:ext cx="360000" cy="360000"/>
+            </a:xfrm>
+            <a:prstGeom prst="roundRect">
+              <a:avLst/>
+            </a:prstGeom>
+            <a:solidFill>
+              <a:schemeClr val="accent3">
+                <a:lumMod val="20000"/>
+                <a:lumOff val="80000"/>
+              </a:schemeClr>
+            </a:solidFill>
+            <a:ln>
+              <a:noFill/>
+            </a:ln>
+          </p:spPr>
+          <p:style>
+            <a:lnRef idx="2">
+              <a:schemeClr val="accent1">
+                <a:shade val="15000"/>
+              </a:schemeClr>
+            </a:lnRef>
+            <a:fillRef idx="1">
+              <a:schemeClr val="accent1"/>
+            </a:fillRef>
+            <a:effectRef idx="0">
+              <a:schemeClr val="accent1"/>
+            </a:effectRef>
+            <a:fontRef idx="minor">
+              <a:schemeClr val="lt1"/>
+            </a:fontRef>
+          </p:style>
+          <p:txBody>
+            <a:bodyPr rtlCol="0" anchor="ctr"/>
+            <a:lstStyle/>
+            <a:p>
+              <a:pPr algn="ctr"/>
+              <a:endParaRPr lang="en-GB" dirty="0"/>
+            </a:p>
+          </p:txBody>
+        </p:sp>
+        <p:sp>
+          <p:nvSpPr>
+            <p:cNvPr id="16" name="TextBox 15">
+              <a:extLst>
+                <a:ext uri="{FF2B5EF4-FFF2-40B4-BE49-F238E27FC236}">
+                  <a16:creationId xmlns:a16="http://schemas.microsoft.com/office/drawing/2014/main" id="{A790F3EB-0D30-940C-5A26-5AEE25C5D7A9}"/>
+                </a:ext>
+              </a:extLst>
+            </p:cNvPr>
+            <p:cNvSpPr txBox="1"/>
+            <p:nvPr/>
+          </p:nvSpPr>
+          <p:spPr>
+            <a:xfrm>
+              <a:off x="697253" y="1058988"/>
+              <a:ext cx="281894" cy="400110"/>
+            </a:xfrm>
+            <a:prstGeom prst="rect">
+              <a:avLst/>
+            </a:prstGeom>
+            <a:noFill/>
+          </p:spPr>
+          <p:txBody>
+            <a:bodyPr wrap="square">
+              <a:spAutoFit/>
+            </a:bodyPr>
+            <a:lstStyle/>
+            <a:p>
+              <a:r>
+                <a:rPr lang="es-ES" sz="2000" b="1" dirty="0"/>
+                <a:t>!</a:t>
+              </a:r>
+            </a:p>
+          </p:txBody>
+        </p:sp>
+      </p:grpSp>
+      <p:grpSp>
+        <p:nvGrpSpPr>
+          <p:cNvPr id="17" name="Group 16">
+            <a:extLst>
+              <a:ext uri="{FF2B5EF4-FFF2-40B4-BE49-F238E27FC236}">
+                <a16:creationId xmlns:a16="http://schemas.microsoft.com/office/drawing/2014/main" id="{90BFE213-C564-568E-9289-4F4194B92811}"/>
+              </a:ext>
+            </a:extLst>
+          </p:cNvPr>
+          <p:cNvGrpSpPr/>
+          <p:nvPr/>
+        </p:nvGrpSpPr>
+        <p:grpSpPr>
+          <a:xfrm>
+            <a:off x="704121" y="5720847"/>
+            <a:ext cx="360000" cy="400110"/>
+            <a:chOff x="658200" y="1058988"/>
+            <a:chExt cx="360000" cy="400110"/>
+          </a:xfrm>
+        </p:grpSpPr>
+        <p:sp>
+          <p:nvSpPr>
+            <p:cNvPr id="18" name="Rectangle: Rounded Corners 17">
+              <a:extLst>
+                <a:ext uri="{FF2B5EF4-FFF2-40B4-BE49-F238E27FC236}">
+                  <a16:creationId xmlns:a16="http://schemas.microsoft.com/office/drawing/2014/main" id="{027292C7-2E00-5F71-B493-B36D6F561D58}"/>
+                </a:ext>
+              </a:extLst>
+            </p:cNvPr>
+            <p:cNvSpPr/>
+            <p:nvPr/>
+          </p:nvSpPr>
+          <p:spPr>
+            <a:xfrm>
+              <a:off x="658200" y="1079043"/>
+              <a:ext cx="360000" cy="360000"/>
+            </a:xfrm>
+            <a:prstGeom prst="roundRect">
+              <a:avLst/>
+            </a:prstGeom>
+            <a:solidFill>
+              <a:schemeClr val="accent3">
+                <a:lumMod val="20000"/>
+                <a:lumOff val="80000"/>
+              </a:schemeClr>
+            </a:solidFill>
+            <a:ln>
+              <a:noFill/>
+            </a:ln>
+          </p:spPr>
+          <p:style>
+            <a:lnRef idx="2">
+              <a:schemeClr val="accent1">
+                <a:shade val="15000"/>
+              </a:schemeClr>
+            </a:lnRef>
+            <a:fillRef idx="1">
+              <a:schemeClr val="accent1"/>
+            </a:fillRef>
+            <a:effectRef idx="0">
+              <a:schemeClr val="accent1"/>
+            </a:effectRef>
+            <a:fontRef idx="minor">
+              <a:schemeClr val="lt1"/>
+            </a:fontRef>
+          </p:style>
+          <p:txBody>
+            <a:bodyPr rtlCol="0" anchor="ctr"/>
+            <a:lstStyle/>
+            <a:p>
+              <a:pPr algn="ctr"/>
+              <a:endParaRPr lang="en-GB" dirty="0"/>
+            </a:p>
+          </p:txBody>
+        </p:sp>
+        <p:sp>
+          <p:nvSpPr>
+            <p:cNvPr id="19" name="TextBox 18">
+              <a:extLst>
+                <a:ext uri="{FF2B5EF4-FFF2-40B4-BE49-F238E27FC236}">
+                  <a16:creationId xmlns:a16="http://schemas.microsoft.com/office/drawing/2014/main" id="{234E3123-9330-64F4-DDD4-EB9FC2F88319}"/>
+                </a:ext>
+              </a:extLst>
+            </p:cNvPr>
+            <p:cNvSpPr txBox="1"/>
+            <p:nvPr/>
+          </p:nvSpPr>
+          <p:spPr>
+            <a:xfrm>
+              <a:off x="697253" y="1058988"/>
+              <a:ext cx="281894" cy="400110"/>
+            </a:xfrm>
+            <a:prstGeom prst="rect">
+              <a:avLst/>
+            </a:prstGeom>
+            <a:noFill/>
+          </p:spPr>
+          <p:txBody>
+            <a:bodyPr wrap="square">
+              <a:spAutoFit/>
+            </a:bodyPr>
+            <a:lstStyle/>
+            <a:p>
+              <a:r>
+                <a:rPr lang="es-ES" sz="2000" b="1" dirty="0"/>
+                <a:t>!</a:t>
+              </a:r>
+            </a:p>
+          </p:txBody>
+        </p:sp>
+      </p:grpSp>
+      <p:pic>
+        <p:nvPicPr>
+          <p:cNvPr id="23" name="Picture 22">
+            <a:extLst>
+              <a:ext uri="{FF2B5EF4-FFF2-40B4-BE49-F238E27FC236}">
+                <a16:creationId xmlns:a16="http://schemas.microsoft.com/office/drawing/2014/main" id="{07D66502-141F-9442-3EAE-DCEFC0189C26}"/>
+              </a:ext>
+            </a:extLst>
+          </p:cNvPr>
+          <p:cNvPicPr>
+            <a:picLocks noChangeAspect="1"/>
+          </p:cNvPicPr>
+          <p:nvPr/>
+        </p:nvPicPr>
+        <p:blipFill>
+          <a:blip r:embed="rId5"/>
+          <a:srcRect b="57092"/>
+          <a:stretch>
+            <a:fillRect/>
+          </a:stretch>
+        </p:blipFill>
+        <p:spPr>
+          <a:xfrm>
+            <a:off x="1449291" y="2865529"/>
+            <a:ext cx="4013362" cy="1544546"/>
+          </a:xfrm>
+          <a:prstGeom prst="rect">
+            <a:avLst/>
+          </a:prstGeom>
+        </p:spPr>
+      </p:pic>
+      <p:pic>
+        <p:nvPicPr>
+          <p:cNvPr id="24" name="Picture 23">
+            <a:extLst>
+              <a:ext uri="{FF2B5EF4-FFF2-40B4-BE49-F238E27FC236}">
+                <a16:creationId xmlns:a16="http://schemas.microsoft.com/office/drawing/2014/main" id="{89F98A83-1F0A-5E37-A4B5-EB2EE40BC814}"/>
+              </a:ext>
+            </a:extLst>
+          </p:cNvPr>
+          <p:cNvPicPr>
+            <a:picLocks noChangeAspect="1"/>
+          </p:cNvPicPr>
+          <p:nvPr/>
+        </p:nvPicPr>
+        <p:blipFill>
+          <a:blip r:embed="rId5"/>
+          <a:srcRect t="40781" b="-1311"/>
+          <a:stretch>
+            <a:fillRect/>
+          </a:stretch>
+        </p:blipFill>
+        <p:spPr>
+          <a:xfrm>
+            <a:off x="6102723" y="2703569"/>
+            <a:ext cx="3675283" cy="1995333"/>
+          </a:xfrm>
+          <a:prstGeom prst="rect">
+            <a:avLst/>
+          </a:prstGeom>
+        </p:spPr>
+      </p:pic>
+      <p:pic>
+        <p:nvPicPr>
+          <p:cNvPr id="25" name="Picture 24">
+            <a:extLst>
+              <a:ext uri="{FF2B5EF4-FFF2-40B4-BE49-F238E27FC236}">
+                <a16:creationId xmlns:a16="http://schemas.microsoft.com/office/drawing/2014/main" id="{C975BB62-A250-349D-7EFC-0F6450C83CA4}"/>
+              </a:ext>
+            </a:extLst>
+          </p:cNvPr>
+          <p:cNvPicPr>
+            <a:picLocks noChangeAspect="1"/>
+          </p:cNvPicPr>
+          <p:nvPr/>
+        </p:nvPicPr>
+        <p:blipFill>
+          <a:blip r:embed="rId5"/>
+          <a:srcRect b="92713"/>
+          <a:stretch>
+            <a:fillRect/>
+          </a:stretch>
+        </p:blipFill>
+        <p:spPr>
+          <a:xfrm>
+            <a:off x="5818266" y="2503539"/>
+            <a:ext cx="4013362" cy="262293"/>
+          </a:xfrm>
+          <a:prstGeom prst="rect">
+            <a:avLst/>
+          </a:prstGeom>
+        </p:spPr>
+      </p:pic>
+    </p:spTree>
+    <p:extLst>
+      <p:ext uri="{BB962C8B-B14F-4D97-AF65-F5344CB8AC3E}">
+        <p14:creationId xmlns:p14="http://schemas.microsoft.com/office/powerpoint/2010/main" val="2950985826"/>
       </p:ext>
     </p:extLst>
   </p:cSld>

</xml_diff>